<commit_message>
Fix tech outline: include L1-L4 headings
</commit_message>
<xml_diff>
--- a/assets/ppt/龙虾框架分享-科技风-提纲版.pptx
+++ b/assets/ppt/龙虾框架分享-科技风-提纲版.pptx
@@ -19831,7 +19831,7 @@
                 <a:ea typeface="Calibri" pitchFamily="34" charset="-122"/>
                 <a:cs typeface="Calibri" pitchFamily="34" charset="-120"/>
               </a:rPr>
-              <a:t>L1 00｜课程导读</a:t>
+              <a:t>L1 龙虾框架分享：从基础应用到商业变现（扩展版）</a:t>
             </a:r>
             <a:endParaRPr lang="en-US" sz="1400" dirty="0"/>
           </a:p>
@@ -19852,12 +19852,12 @@
                 <a:ea typeface="Calibri" pitchFamily="34" charset="-122"/>
                 <a:cs typeface="Calibri" pitchFamily="34" charset="-120"/>
               </a:rPr>
-              <a:t>L2 课程定位</a:t>
+              <a:t>L2 00｜课程导读</a:t>
             </a:r>
             <a:endParaRPr lang="en-US" sz="1400" dirty="0"/>
           </a:p>
           <a:p>
-            <a:pPr lvl="1" marL="685800" indent="-342900">
+            <a:pPr lvl="2" marL="1028700" indent="-342900">
               <a:spcAft>
                 <a:spcPts val="400"/>
               </a:spcAft>
@@ -19873,12 +19873,12 @@
                 <a:ea typeface="Calibri" pitchFamily="34" charset="-122"/>
                 <a:cs typeface="Calibri" pitchFamily="34" charset="-120"/>
               </a:rPr>
-              <a:t>L2 适合人群</a:t>
+              <a:t>L3 课程定位</a:t>
             </a:r>
             <a:endParaRPr lang="en-US" sz="1400" dirty="0"/>
           </a:p>
           <a:p>
-            <a:pPr lvl="1" marL="685800" indent="-342900">
+            <a:pPr lvl="2" marL="1028700" indent="-342900">
               <a:spcAft>
                 <a:spcPts val="400"/>
               </a:spcAft>
@@ -19894,12 +19894,12 @@
                 <a:ea typeface="Calibri" pitchFamily="34" charset="-122"/>
                 <a:cs typeface="Calibri" pitchFamily="34" charset="-120"/>
               </a:rPr>
-              <a:t>L2 学完你能得到什么（可验收）</a:t>
+              <a:t>L3 适合人群</a:t>
             </a:r>
             <a:endParaRPr lang="en-US" sz="1400" dirty="0"/>
           </a:p>
           <a:p>
-            <a:pPr lvl="1" marL="685800" indent="-342900">
+            <a:pPr lvl="2" marL="1028700" indent="-342900">
               <a:spcAft>
                 <a:spcPts val="400"/>
               </a:spcAft>
@@ -19915,12 +19915,12 @@
                 <a:ea typeface="Calibri" pitchFamily="34" charset="-122"/>
                 <a:cs typeface="Calibri" pitchFamily="34" charset="-120"/>
               </a:rPr>
-              <a:t>L2 课程结构（目录）</a:t>
+              <a:t>L3 学完你能得到什么（可验收）</a:t>
             </a:r>
             <a:endParaRPr lang="en-US" sz="1400" dirty="0"/>
           </a:p>
           <a:p>
-            <a:pPr lvl="1" marL="685800" indent="-342900">
+            <a:pPr lvl="2" marL="1028700" indent="-342900">
               <a:spcAft>
                 <a:spcPts val="400"/>
               </a:spcAft>
@@ -19936,12 +19936,12 @@
                 <a:ea typeface="Calibri" pitchFamily="34" charset="-122"/>
                 <a:cs typeface="Calibri" pitchFamily="34" charset="-120"/>
               </a:rPr>
-              <a:t>L2 章节目标一览（课件版）</a:t>
+              <a:t>L3 课程结构（目录）</a:t>
             </a:r>
             <a:endParaRPr lang="en-US" sz="1400" dirty="0"/>
           </a:p>
           <a:p>
-            <a:pPr lvl="1" marL="685800" indent="-342900">
+            <a:pPr lvl="2" marL="1028700" indent="-342900">
               <a:spcAft>
                 <a:spcPts val="400"/>
               </a:spcAft>
@@ -19957,12 +19957,12 @@
                 <a:ea typeface="Calibri" pitchFamily="34" charset="-122"/>
                 <a:cs typeface="Calibri" pitchFamily="34" charset="-120"/>
               </a:rPr>
-              <a:t>L2 使用建议</a:t>
+              <a:t>L3 章节目标一览（课件版）</a:t>
             </a:r>
             <a:endParaRPr lang="en-US" sz="1400" dirty="0"/>
           </a:p>
           <a:p>
-            <a:pPr marL="342900" indent="-342900">
+            <a:pPr lvl="2" marL="1028700" indent="-342900">
               <a:spcAft>
                 <a:spcPts val="400"/>
               </a:spcAft>
@@ -19978,7 +19978,7 @@
                 <a:ea typeface="Calibri" pitchFamily="34" charset="-122"/>
                 <a:cs typeface="Calibri" pitchFamily="34" charset="-120"/>
               </a:rPr>
-              <a:t>L1 01｜第一章节：龙虾是什么？</a:t>
+              <a:t>L3 使用建议</a:t>
             </a:r>
             <a:endParaRPr lang="en-US" sz="1400" dirty="0"/>
           </a:p>
@@ -19999,12 +19999,12 @@
                 <a:ea typeface="Calibri" pitchFamily="34" charset="-122"/>
                 <a:cs typeface="Calibri" pitchFamily="34" charset="-120"/>
               </a:rPr>
-              <a:t>L2 你要讲的“真实起因”（可直接当演讲素材）</a:t>
+              <a:t>L2 01｜第一章节：龙虾是什么？</a:t>
             </a:r>
             <a:endParaRPr lang="en-US" sz="1400" dirty="0"/>
           </a:p>
           <a:p>
-            <a:pPr lvl="1" marL="685800" indent="-342900">
+            <a:pPr lvl="2" marL="1028700" indent="-342900">
               <a:spcAft>
                 <a:spcPts val="400"/>
               </a:spcAft>
@@ -20020,12 +20020,12 @@
                 <a:ea typeface="Calibri" pitchFamily="34" charset="-122"/>
                 <a:cs typeface="Calibri" pitchFamily="34" charset="-120"/>
               </a:rPr>
-              <a:t>L2 互联网补充：你说的“后面那几个”也补进来（出圈事件 + 大迁移）</a:t>
+              <a:t>L3 你要讲的“真实起因”（可直接当演讲素材）</a:t>
             </a:r>
             <a:endParaRPr lang="en-US" sz="1400" dirty="0"/>
           </a:p>
           <a:p>
-            <a:pPr lvl="1" marL="685800" indent="-342900">
+            <a:pPr lvl="2" marL="1028700" indent="-342900">
               <a:spcAft>
                 <a:spcPts val="400"/>
               </a:spcAft>
@@ -20041,12 +20041,12 @@
                 <a:ea typeface="Calibri" pitchFamily="34" charset="-122"/>
                 <a:cs typeface="Calibri" pitchFamily="34" charset="-120"/>
               </a:rPr>
-              <a:t>L2 互联网补充：OpenClaw 的“框架”（你第一章要讲的系统结构）</a:t>
+              <a:t>L3 互联网补充：你说的“后面那几个”也补进来（出圈事件 + 大迁移）</a:t>
             </a:r>
             <a:endParaRPr lang="en-US" sz="1400" dirty="0"/>
           </a:p>
           <a:p>
-            <a:pPr lvl="1" marL="685800" indent="-342900">
+            <a:pPr lvl="2" marL="1028700" indent="-342900">
               <a:spcAft>
                 <a:spcPts val="400"/>
               </a:spcAft>
@@ -20062,12 +20062,12 @@
                 <a:ea typeface="Calibri" pitchFamily="34" charset="-122"/>
                 <a:cs typeface="Calibri" pitchFamily="34" charset="-120"/>
               </a:rPr>
-              <a:t>L2 原始要点</a:t>
+              <a:t>L3 互联网补充：OpenClaw 的“框架”（你第一章要讲的系统结构）</a:t>
             </a:r>
             <a:endParaRPr lang="en-US" sz="1400" dirty="0"/>
           </a:p>
           <a:p>
-            <a:pPr lvl="1" marL="685800" indent="-342900">
+            <a:pPr lvl="2" marL="1028700" indent="-342900">
               <a:spcAft>
                 <a:spcPts val="400"/>
               </a:spcAft>
@@ -20083,12 +20083,12 @@
                 <a:ea typeface="Calibri" pitchFamily="34" charset="-122"/>
                 <a:cs typeface="Calibri" pitchFamily="34" charset="-120"/>
               </a:rPr>
-              <a:t>L2 互联网补充：什么叫“channel / 最后一公里”？</a:t>
+              <a:t>L3 原始要点</a:t>
             </a:r>
             <a:endParaRPr lang="en-US" sz="1400" dirty="0"/>
           </a:p>
           <a:p>
-            <a:pPr lvl="1" marL="685800" indent="-342900">
+            <a:pPr lvl="2" marL="1028700" indent="-342900">
               <a:spcAft>
                 <a:spcPts val="400"/>
               </a:spcAft>
@@ -20104,12 +20104,12 @@
                 <a:ea typeface="Calibri" pitchFamily="34" charset="-122"/>
                 <a:cs typeface="Calibri" pitchFamily="34" charset="-120"/>
               </a:rPr>
-              <a:t>L2 可直接复用的“龙虾框架（定义版）”</a:t>
+              <a:t>L3 互联网补充：什么叫“channel / 最后一公里”？</a:t>
             </a:r>
             <a:endParaRPr lang="en-US" sz="1400" dirty="0"/>
           </a:p>
           <a:p>
-            <a:pPr marL="342900" indent="-342900">
+            <a:pPr lvl="2" marL="1028700" indent="-342900">
               <a:spcAft>
                 <a:spcPts val="400"/>
               </a:spcAft>
@@ -20125,7 +20125,7 @@
                 <a:ea typeface="Calibri" pitchFamily="34" charset="-122"/>
                 <a:cs typeface="Calibri" pitchFamily="34" charset="-120"/>
               </a:rPr>
-              <a:t>L1 02｜第二章节：龙虾能干什么？</a:t>
+              <a:t>L3 可直接复用的“龙虾框架（定义版）”</a:t>
             </a:r>
             <a:endParaRPr lang="en-US" sz="1400" dirty="0"/>
           </a:p>
@@ -20146,12 +20146,12 @@
                 <a:ea typeface="Calibri" pitchFamily="34" charset="-122"/>
                 <a:cs typeface="Calibri" pitchFamily="34" charset="-120"/>
               </a:rPr>
-              <a:t>L2 原始要点</a:t>
+              <a:t>L2 02｜第二章节：龙虾能干什么？</a:t>
             </a:r>
             <a:endParaRPr lang="en-US" sz="1400" dirty="0"/>
           </a:p>
           <a:p>
-            <a:pPr lvl="1" marL="685800" indent="-342900">
+            <a:pPr lvl="2" marL="1028700" indent="-342900">
               <a:spcAft>
                 <a:spcPts val="400"/>
               </a:spcAft>
@@ -20167,12 +20167,12 @@
                 <a:ea typeface="Calibri" pitchFamily="34" charset="-122"/>
                 <a:cs typeface="Calibri" pitchFamily="34" charset="-120"/>
               </a:rPr>
-              <a:t>L2 互联网补充：Skill 的“产品化定义”</a:t>
+              <a:t>L3 原始要点</a:t>
             </a:r>
             <a:endParaRPr lang="en-US" sz="1400" dirty="0"/>
           </a:p>
           <a:p>
-            <a:pPr lvl="1" marL="685800" indent="-342900">
+            <a:pPr lvl="2" marL="1028700" indent="-342900">
               <a:spcAft>
                 <a:spcPts val="400"/>
               </a:spcAft>
@@ -20188,7 +20188,7 @@
                 <a:ea typeface="Calibri" pitchFamily="34" charset="-122"/>
                 <a:cs typeface="Calibri" pitchFamily="34" charset="-120"/>
               </a:rPr>
-              <a:t>L2 建议展示方式：从“点技能”升级到“端到端结果”</a:t>
+              <a:t>L3 互联网补充：Skill 的“产品化定义”</a:t>
             </a:r>
             <a:endParaRPr lang="en-US" sz="1400" dirty="0"/>
           </a:p>
@@ -20943,7 +20943,7 @@
           <a:bodyPr wrap="square" lIns="0" tIns="0" rIns="0" bIns="0" rtlCol="0" anchor="t"/>
           <a:lstStyle/>
           <a:p>
-            <a:pPr marL="342900" indent="-342900">
+            <a:pPr lvl="2" marL="1028700" indent="-342900">
               <a:spcAft>
                 <a:spcPts val="400"/>
               </a:spcAft>
@@ -20959,7 +20959,7 @@
                 <a:ea typeface="Calibri" pitchFamily="34" charset="-122"/>
                 <a:cs typeface="Calibri" pitchFamily="34" charset="-120"/>
               </a:rPr>
-              <a:t>L1 03｜第三章节：如何养成这样的龙虾？</a:t>
+              <a:t>L3 建议展示方式：从“点技能”升级到“端到端结果”</a:t>
             </a:r>
             <a:endParaRPr lang="en-US" sz="1400" dirty="0"/>
           </a:p>
@@ -20980,12 +20980,12 @@
                 <a:ea typeface="Calibri" pitchFamily="34" charset="-122"/>
                 <a:cs typeface="Calibri" pitchFamily="34" charset="-120"/>
               </a:rPr>
-              <a:t>L2 原始要点</a:t>
+              <a:t>L2 03｜第三章节：如何养成这样的龙虾？</a:t>
             </a:r>
             <a:endParaRPr lang="en-US" sz="1400" dirty="0"/>
           </a:p>
           <a:p>
-            <a:pPr lvl="1" marL="685800" indent="-342900">
+            <a:pPr lvl="2" marL="1028700" indent="-342900">
               <a:spcAft>
                 <a:spcPts val="400"/>
               </a:spcAft>
@@ -21001,12 +21001,12 @@
                 <a:ea typeface="Calibri" pitchFamily="34" charset="-122"/>
                 <a:cs typeface="Calibri" pitchFamily="34" charset="-120"/>
               </a:rPr>
-              <a:t>L2 互联网补充：为什么“写进文件”才算养成？（Memory / Workspace）</a:t>
+              <a:t>L3 原始要点</a:t>
             </a:r>
             <a:endParaRPr lang="en-US" sz="1400" dirty="0"/>
           </a:p>
           <a:p>
-            <a:pPr lvl="1" marL="685800" indent="-342900">
+            <a:pPr lvl="2" marL="1028700" indent="-342900">
               <a:spcAft>
                 <a:spcPts val="400"/>
               </a:spcAft>
@@ -21022,12 +21022,12 @@
                 <a:ea typeface="Calibri" pitchFamily="34" charset="-122"/>
                 <a:cs typeface="Calibri" pitchFamily="34" charset="-120"/>
               </a:rPr>
-              <a:t>L2 一套更可操作的“养龙虾路线图”（从新手到可商用）</a:t>
+              <a:t>L3 互联网补充：为什么“写进文件”才算养成？（Memory / Workspace）</a:t>
             </a:r>
             <a:endParaRPr lang="en-US" sz="1400" dirty="0"/>
           </a:p>
           <a:p>
-            <a:pPr marL="342900" indent="-342900">
+            <a:pPr lvl="2" marL="1028700" indent="-342900">
               <a:spcAft>
                 <a:spcPts val="400"/>
               </a:spcAft>
@@ -21043,7 +21043,7 @@
                 <a:ea typeface="Calibri" pitchFamily="34" charset="-122"/>
                 <a:cs typeface="Calibri" pitchFamily="34" charset="-120"/>
               </a:rPr>
-              <a:t>L1 04｜组织变革：从超级个体到一人公司</a:t>
+              <a:t>L3 一套更可操作的“养龙虾路线图”（从新手到可商用）</a:t>
             </a:r>
             <a:endParaRPr lang="en-US" sz="1400" dirty="0"/>
           </a:p>
@@ -21064,12 +21064,12 @@
                 <a:ea typeface="Calibri" pitchFamily="34" charset="-122"/>
                 <a:cs typeface="Calibri" pitchFamily="34" charset="-120"/>
               </a:rPr>
-              <a:t>L2 原始要点</a:t>
+              <a:t>L2 04｜组织变革：从超级个体到一人公司</a:t>
             </a:r>
             <a:endParaRPr lang="en-US" sz="1400" dirty="0"/>
           </a:p>
           <a:p>
-            <a:pPr lvl="1" marL="685800" indent="-342900">
+            <a:pPr lvl="2" marL="1028700" indent="-342900">
               <a:spcAft>
                 <a:spcPts val="400"/>
               </a:spcAft>
@@ -21085,12 +21085,12 @@
                 <a:ea typeface="Calibri" pitchFamily="34" charset="-122"/>
                 <a:cs typeface="Calibri" pitchFamily="34" charset="-120"/>
               </a:rPr>
-              <a:t>L2 互联网补充：Multi-Agent 的“隔离”是组织成立的前提</a:t>
+              <a:t>L3 原始要点</a:t>
             </a:r>
             <a:endParaRPr lang="en-US" sz="1400" dirty="0"/>
           </a:p>
           <a:p>
-            <a:pPr lvl="1" marL="685800" indent="-342900">
+            <a:pPr lvl="2" marL="1028700" indent="-342900">
               <a:spcAft>
                 <a:spcPts val="400"/>
               </a:spcAft>
@@ -21106,12 +21106,12 @@
                 <a:ea typeface="Calibri" pitchFamily="34" charset="-122"/>
                 <a:cs typeface="Calibri" pitchFamily="34" charset="-120"/>
               </a:rPr>
-              <a:t>L2 可直接拿来讲的“组织架构 3 套模板”</a:t>
+              <a:t>L3 互联网补充：Multi-Agent 的“隔离”是组织成立的前提</a:t>
             </a:r>
             <a:endParaRPr lang="en-US" sz="1400" dirty="0"/>
           </a:p>
           <a:p>
-            <a:pPr marL="342900" indent="-342900">
+            <a:pPr lvl="2" marL="1028700" indent="-342900">
               <a:spcAft>
                 <a:spcPts val="400"/>
               </a:spcAft>
@@ -21127,7 +21127,7 @@
                 <a:ea typeface="Calibri" pitchFamily="34" charset="-122"/>
                 <a:cs typeface="Calibri" pitchFamily="34" charset="-120"/>
               </a:rPr>
-              <a:t>L1 05｜第四章：Agent 与人机结合（先别急着做）</a:t>
+              <a:t>L3 可直接拿来讲的“组织架构 3 套模板”</a:t>
             </a:r>
             <a:endParaRPr lang="en-US" sz="1400" dirty="0"/>
           </a:p>
@@ -21148,12 +21148,12 @@
                 <a:ea typeface="Calibri" pitchFamily="34" charset="-122"/>
                 <a:cs typeface="Calibri" pitchFamily="34" charset="-120"/>
               </a:rPr>
-              <a:t>L2 原始要点</a:t>
+              <a:t>L2 05｜第四章：Agent 与人机结合（先别急着做）</a:t>
             </a:r>
             <a:endParaRPr lang="en-US" sz="1400" dirty="0"/>
           </a:p>
           <a:p>
-            <a:pPr lvl="1" marL="685800" indent="-342900">
+            <a:pPr lvl="2" marL="1028700" indent="-342900">
               <a:spcAft>
                 <a:spcPts val="400"/>
               </a:spcAft>
@@ -21169,12 +21169,12 @@
                 <a:ea typeface="Calibri" pitchFamily="34" charset="-122"/>
                 <a:cs typeface="Calibri" pitchFamily="34" charset="-120"/>
               </a:rPr>
-              <a:t>L2 互联网补充 1：Agent Loop 视角——“人机结合”其实是流水线设计</a:t>
+              <a:t>L3 原始要点</a:t>
             </a:r>
             <a:endParaRPr lang="en-US" sz="1400" dirty="0"/>
           </a:p>
           <a:p>
-            <a:pPr lvl="1" marL="685800" indent="-342900">
+            <a:pPr lvl="2" marL="1028700" indent="-342900">
               <a:spcAft>
                 <a:spcPts val="400"/>
               </a:spcAft>
@@ -21190,12 +21190,12 @@
                 <a:ea typeface="Calibri" pitchFamily="34" charset="-122"/>
                 <a:cs typeface="Calibri" pitchFamily="34" charset="-120"/>
               </a:rPr>
-              <a:t>L2 互联网补充 2：什么时候该“委派给 AI”？（管理学视角）</a:t>
+              <a:t>L3 互联网补充 1：Agent Loop 视角——“人机结合”其实是流水线设计</a:t>
             </a:r>
             <a:endParaRPr lang="en-US" sz="1400" dirty="0"/>
           </a:p>
           <a:p>
-            <a:pPr lvl="1" marL="685800" indent="-342900">
+            <a:pPr lvl="2" marL="1028700" indent="-342900">
               <a:spcAft>
                 <a:spcPts val="400"/>
               </a:spcAft>
@@ -21211,12 +21211,12 @@
                 <a:ea typeface="Calibri" pitchFamily="34" charset="-122"/>
                 <a:cs typeface="Calibri" pitchFamily="34" charset="-120"/>
               </a:rPr>
-              <a:t>L2 “双 S SOP”建议写法（更落地）</a:t>
+              <a:t>L3 互联网补充 2：什么时候该“委派给 AI”？（管理学视角）</a:t>
             </a:r>
             <a:endParaRPr lang="en-US" sz="1400" dirty="0"/>
           </a:p>
           <a:p>
-            <a:pPr marL="342900" indent="-342900">
+            <a:pPr lvl="2" marL="1028700" indent="-342900">
               <a:spcAft>
                 <a:spcPts val="400"/>
               </a:spcAft>
@@ -21232,7 +21232,7 @@
                 <a:ea typeface="Calibri" pitchFamily="34" charset="-122"/>
                 <a:cs typeface="Calibri" pitchFamily="34" charset="-120"/>
               </a:rPr>
-              <a:t>L1 06｜第五章节：第一波龙虾如何挣钱？（Skill 如何挣钱？）</a:t>
+              <a:t>L3 “双 S SOP”建议写法（更落地）</a:t>
             </a:r>
             <a:endParaRPr lang="en-US" sz="1400" dirty="0"/>
           </a:p>
@@ -21253,12 +21253,12 @@
                 <a:ea typeface="Calibri" pitchFamily="34" charset="-122"/>
                 <a:cs typeface="Calibri" pitchFamily="34" charset="-120"/>
               </a:rPr>
-              <a:t>L2 原始要点</a:t>
+              <a:t>L2 06｜第五章节：第一波龙虾如何挣钱？（Skill 如何挣钱？）</a:t>
             </a:r>
             <a:endParaRPr lang="en-US" sz="1400" dirty="0"/>
           </a:p>
           <a:p>
-            <a:pPr lvl="1" marL="685800" indent="-342900">
+            <a:pPr lvl="2" marL="1028700" indent="-342900">
               <a:spcAft>
                 <a:spcPts val="400"/>
               </a:spcAft>
@@ -21274,12 +21274,12 @@
                 <a:ea typeface="Calibri" pitchFamily="34" charset="-122"/>
                 <a:cs typeface="Calibri" pitchFamily="34" charset="-120"/>
               </a:rPr>
-              <a:t>L2 互联网补充 1：为什么“Skill 能挣钱”（因为它天然可被版本化/分发/复用）</a:t>
+              <a:t>L3 原始要点</a:t>
             </a:r>
             <a:endParaRPr lang="en-US" sz="1400" dirty="0"/>
           </a:p>
           <a:p>
-            <a:pPr lvl="1" marL="685800" indent="-342900">
+            <a:pPr lvl="2" marL="1028700" indent="-342900">
               <a:spcAft>
                 <a:spcPts val="400"/>
               </a:spcAft>
@@ -21295,12 +21295,12 @@
                 <a:ea typeface="Calibri" pitchFamily="34" charset="-122"/>
                 <a:cs typeface="Calibri" pitchFamily="34" charset="-120"/>
               </a:rPr>
-              <a:t>L2 互联网补充 2：Skill 变现的 6 种更具体路径（可直接做一页）</a:t>
+              <a:t>L3 互联网补充 1：为什么“Skill 能挣钱”（因为它天然可被版本化/分发/复用）</a:t>
             </a:r>
             <a:endParaRPr lang="en-US" sz="1400" dirty="0"/>
           </a:p>
           <a:p>
-            <a:pPr lvl="1" marL="685800" indent="-342900">
+            <a:pPr lvl="2" marL="1028700" indent="-342900">
               <a:spcAft>
                 <a:spcPts val="400"/>
               </a:spcAft>
@@ -21316,7 +21316,7 @@
                 <a:ea typeface="Calibri" pitchFamily="34" charset="-122"/>
                 <a:cs typeface="Calibri" pitchFamily="34" charset="-120"/>
               </a:rPr>
-              <a:t>L2 互联网补充 3：从“代练”到“产品化”的常见路径（你原来的逻辑保留）</a:t>
+              <a:t>L3 互联网补充 2：Skill 变现的 6 种更具体路径（可直接做一页）</a:t>
             </a:r>
             <a:endParaRPr lang="en-US" sz="1400" dirty="0"/>
           </a:p>
@@ -22071,7 +22071,7 @@
           <a:bodyPr wrap="square" lIns="0" tIns="0" rIns="0" bIns="0" rtlCol="0" anchor="t"/>
           <a:lstStyle/>
           <a:p>
-            <a:pPr marL="342900" indent="-342900">
+            <a:pPr lvl="2" marL="1028700" indent="-342900">
               <a:spcAft>
                 <a:spcPts val="400"/>
               </a:spcAft>
@@ -22087,7 +22087,7 @@
                 <a:ea typeface="Calibri" pitchFamily="34" charset="-122"/>
                 <a:cs typeface="Calibri" pitchFamily="34" charset="-120"/>
               </a:rPr>
-              <a:t>L1 07｜第六个话题：SaaS 产品如何突围？（SaaS 如何和龙虾/OpenClaw 结合？）</a:t>
+              <a:t>L3 互联网补充 3：从“代练”到“产品化”的常见路径（你原来的逻辑保留）</a:t>
             </a:r>
             <a:endParaRPr lang="en-US" sz="1400" dirty="0"/>
           </a:p>
@@ -22108,12 +22108,12 @@
                 <a:ea typeface="Calibri" pitchFamily="34" charset="-122"/>
                 <a:cs typeface="Calibri" pitchFamily="34" charset="-120"/>
               </a:rPr>
-              <a:t>L2 原始要点</a:t>
+              <a:t>L2 07｜第六个话题：SaaS 产品如何突围？（SaaS 如何和龙虾/OpenClaw 结合？）</a:t>
             </a:r>
             <a:endParaRPr lang="en-US" sz="1400" dirty="0"/>
           </a:p>
           <a:p>
-            <a:pPr lvl="1" marL="685800" indent="-342900">
+            <a:pPr lvl="2" marL="1028700" indent="-342900">
               <a:spcAft>
                 <a:spcPts val="400"/>
               </a:spcAft>
@@ -22129,12 +22129,12 @@
                 <a:ea typeface="Calibri" pitchFamily="34" charset="-122"/>
                 <a:cs typeface="Calibri" pitchFamily="34" charset="-120"/>
               </a:rPr>
-              <a:t>L2 互联网补充 1：OpenClaw 的定位决定了“怎么结合”</a:t>
+              <a:t>L3 原始要点</a:t>
             </a:r>
             <a:endParaRPr lang="en-US" sz="1400" dirty="0"/>
           </a:p>
           <a:p>
-            <a:pPr lvl="1" marL="685800" indent="-342900">
+            <a:pPr lvl="2" marL="1028700" indent="-342900">
               <a:spcAft>
                 <a:spcPts val="400"/>
               </a:spcAft>
@@ -22150,12 +22150,12 @@
                 <a:ea typeface="Calibri" pitchFamily="34" charset="-122"/>
                 <a:cs typeface="Calibri" pitchFamily="34" charset="-120"/>
               </a:rPr>
-              <a:t>L2 互联网补充 2：SaaS × OpenClaw 的 5 种具体结合方式（从轻到重）</a:t>
+              <a:t>L3 互联网补充 1：OpenClaw 的定位决定了“怎么结合”</a:t>
             </a:r>
             <a:endParaRPr lang="en-US" sz="1400" dirty="0"/>
           </a:p>
           <a:p>
-            <a:pPr lvl="1" marL="685800" indent="-342900">
+            <a:pPr lvl="2" marL="1028700" indent="-342900">
               <a:spcAft>
                 <a:spcPts val="400"/>
               </a:spcAft>
@@ -22171,12 +22171,12 @@
                 <a:ea typeface="Calibri" pitchFamily="34" charset="-122"/>
                 <a:cs typeface="Calibri" pitchFamily="34" charset="-120"/>
               </a:rPr>
-              <a:t>L2 互联网补充 3：为什么“channel 是破局点”（更贴近 OpenClaw 特色）</a:t>
+              <a:t>L3 互联网补充 2：SaaS × OpenClaw 的 5 种具体结合方式（从轻到重）</a:t>
             </a:r>
             <a:endParaRPr lang="en-US" sz="1400" dirty="0"/>
           </a:p>
           <a:p>
-            <a:pPr marL="342900" indent="-342900">
+            <a:pPr lvl="2" marL="1028700" indent="-342900">
               <a:spcAft>
                 <a:spcPts val="400"/>
               </a:spcAft>
@@ -22192,7 +22192,7 @@
                 <a:ea typeface="Calibri" pitchFamily="34" charset="-122"/>
                 <a:cs typeface="Calibri" pitchFamily="34" charset="-120"/>
               </a:rPr>
-              <a:t>L1 08｜企业为什么要更早抓紧龙虾？（2B 总论）</a:t>
+              <a:t>L3 互联网补充 3：为什么“channel 是破局点”（更贴近 OpenClaw 特色）</a:t>
             </a:r>
             <a:endParaRPr lang="en-US" sz="1400" dirty="0"/>
           </a:p>
@@ -22213,12 +22213,12 @@
                 <a:ea typeface="Calibri" pitchFamily="34" charset="-122"/>
                 <a:cs typeface="Calibri" pitchFamily="34" charset="-120"/>
               </a:rPr>
-              <a:t>L2 08.1 企业早抓的本质：先抢“入口”和“流程主导权”</a:t>
+              <a:t>L2 08｜企业为什么要更早抓紧龙虾？（2B 总论）</a:t>
             </a:r>
             <a:endParaRPr lang="en-US" sz="1400" dirty="0"/>
           </a:p>
           <a:p>
-            <a:pPr lvl="1" marL="685800" indent="-342900">
+            <a:pPr lvl="2" marL="1028700" indent="-342900">
               <a:spcAft>
                 <a:spcPts val="400"/>
               </a:spcAft>
@@ -22234,12 +22234,12 @@
                 <a:ea typeface="Calibri" pitchFamily="34" charset="-122"/>
                 <a:cs typeface="Calibri" pitchFamily="34" charset="-120"/>
               </a:rPr>
-              <a:t>L2 08.2 企业落地最小闭环（推荐 2 周内做出来）</a:t>
+              <a:t>L3 08.1 企业早抓的本质：先抢“入口”和“流程主导权”</a:t>
             </a:r>
             <a:endParaRPr lang="en-US" sz="1400" dirty="0"/>
           </a:p>
           <a:p>
-            <a:pPr lvl="1" marL="685800" indent="-342900">
+            <a:pPr lvl="2" marL="1028700" indent="-342900">
               <a:spcAft>
                 <a:spcPts val="400"/>
               </a:spcAft>
@@ -22255,12 +22255,12 @@
                 <a:ea typeface="Calibri" pitchFamily="34" charset="-122"/>
                 <a:cs typeface="Calibri" pitchFamily="34" charset="-120"/>
               </a:rPr>
-              <a:t>L2 08.3 风险与治理：企业敢用的关键，是“默认安全”</a:t>
+              <a:t>L3 08.2 企业落地最小闭环（推荐 2 周内做出来）</a:t>
             </a:r>
             <a:endParaRPr lang="en-US" sz="1400" dirty="0"/>
           </a:p>
           <a:p>
-            <a:pPr lvl="1" marL="685800" indent="-342900">
+            <a:pPr lvl="2" marL="1028700" indent="-342900">
               <a:spcAft>
                 <a:spcPts val="400"/>
               </a:spcAft>
@@ -22276,12 +22276,12 @@
                 <a:ea typeface="Calibri" pitchFamily="34" charset="-122"/>
                 <a:cs typeface="Calibri" pitchFamily="34" charset="-120"/>
               </a:rPr>
-              <a:t>L2 08.4 企业“可复制”的组织打法：多 Agent = 多岗位</a:t>
+              <a:t>L3 08.3 风险与治理：企业敢用的关键，是“默认安全”</a:t>
             </a:r>
             <a:endParaRPr lang="en-US" sz="1400" dirty="0"/>
           </a:p>
           <a:p>
-            <a:pPr marL="342900" indent="-342900">
+            <a:pPr lvl="2" marL="1028700" indent="-342900">
               <a:spcAft>
                 <a:spcPts val="400"/>
               </a:spcAft>
@@ -22297,7 +22297,7 @@
                 <a:ea typeface="Calibri" pitchFamily="34" charset="-122"/>
                 <a:cs typeface="Calibri" pitchFamily="34" charset="-120"/>
               </a:rPr>
-              <a:t>L1 09｜SaaS 企业：怎么和龙虾/OpenClaw 结合（实战 + 效果）</a:t>
+              <a:t>L3 08.4 企业“可复制”的组织打法：多 Agent = 多岗位</a:t>
             </a:r>
             <a:endParaRPr lang="en-US" sz="1400" dirty="0"/>
           </a:p>
@@ -22318,12 +22318,12 @@
                 <a:ea typeface="Calibri" pitchFamily="34" charset="-122"/>
                 <a:cs typeface="Calibri" pitchFamily="34" charset="-120"/>
               </a:rPr>
-              <a:t>L2 09.1 典型 SaaS 痛点（高频且可量化）</a:t>
+              <a:t>L2 09｜SaaS 企业：怎么和龙虾/OpenClaw 结合（实战 + 效果）</a:t>
             </a:r>
             <a:endParaRPr lang="en-US" sz="1400" dirty="0"/>
           </a:p>
           <a:p>
-            <a:pPr lvl="1" marL="685800" indent="-342900">
+            <a:pPr lvl="2" marL="1028700" indent="-342900">
               <a:spcAft>
                 <a:spcPts val="400"/>
               </a:spcAft>
@@ -22339,12 +22339,12 @@
                 <a:ea typeface="Calibri" pitchFamily="34" charset="-122"/>
                 <a:cs typeface="Calibri" pitchFamily="34" charset="-120"/>
               </a:rPr>
-              <a:t>L2 09.2 结合方式（按落地难度从轻到重）</a:t>
+              <a:t>L3 09.1 典型 SaaS 痛点（高频且可量化）</a:t>
             </a:r>
             <a:endParaRPr lang="en-US" sz="1400" dirty="0"/>
           </a:p>
           <a:p>
-            <a:pPr lvl="1" marL="685800" indent="-342900">
+            <a:pPr lvl="2" marL="1028700" indent="-342900">
               <a:spcAft>
                 <a:spcPts val="400"/>
               </a:spcAft>
@@ -22360,12 +22360,12 @@
                 <a:ea typeface="Calibri" pitchFamily="34" charset="-122"/>
                 <a:cs typeface="Calibri" pitchFamily="34" charset="-120"/>
               </a:rPr>
-              <a:t>L2 09.3 3 个 SaaS 实战剧本（可直接照做）</a:t>
+              <a:t>L3 09.2 结合方式（按落地难度从轻到重）</a:t>
             </a:r>
             <a:endParaRPr lang="en-US" sz="1400" dirty="0"/>
           </a:p>
           <a:p>
-            <a:pPr lvl="1" marL="685800" indent="-342900">
+            <a:pPr lvl="2" marL="1028700" indent="-342900">
               <a:spcAft>
                 <a:spcPts val="400"/>
               </a:spcAft>
@@ -22381,12 +22381,12 @@
                 <a:ea typeface="Calibri" pitchFamily="34" charset="-122"/>
                 <a:cs typeface="Calibri" pitchFamily="34" charset="-120"/>
               </a:rPr>
-              <a:t>L2 09.4 SaaS 预期效果怎么讲（别用空话，用指标）</a:t>
+              <a:t>L3 09.3 3 个 SaaS 实战剧本（可直接照做）</a:t>
             </a:r>
             <a:endParaRPr lang="en-US" sz="1400" dirty="0"/>
           </a:p>
           <a:p>
-            <a:pPr marL="342900" indent="-342900">
+            <a:pPr lvl="2" marL="1028700" indent="-342900">
               <a:spcAft>
                 <a:spcPts val="400"/>
               </a:spcAft>
@@ -22402,7 +22402,7 @@
                 <a:ea typeface="Calibri" pitchFamily="34" charset="-122"/>
                 <a:cs typeface="Calibri" pitchFamily="34" charset="-120"/>
               </a:rPr>
-              <a:t>L1 10｜外贸电商：询盘到订单的龙虾打法（实战 + 效果）</a:t>
+              <a:t>L3 09.4 SaaS 预期效果怎么讲（别用空话，用指标）</a:t>
             </a:r>
             <a:endParaRPr lang="en-US" sz="1400" dirty="0"/>
           </a:p>
@@ -22423,12 +22423,12 @@
                 <a:ea typeface="Calibri" pitchFamily="34" charset="-122"/>
                 <a:cs typeface="Calibri" pitchFamily="34" charset="-120"/>
               </a:rPr>
-              <a:t>L2 10.1 外贸电商的“高价值环节”在哪里</a:t>
+              <a:t>L2 10｜外贸电商：询盘到订单的龙虾打法（实战 + 效果）</a:t>
             </a:r>
             <a:endParaRPr lang="en-US" sz="1400" dirty="0"/>
           </a:p>
           <a:p>
-            <a:pPr lvl="1" marL="685800" indent="-342900">
+            <a:pPr lvl="2" marL="1028700" indent="-342900">
               <a:spcAft>
                 <a:spcPts val="400"/>
               </a:spcAft>
@@ -22444,7 +22444,7 @@
                 <a:ea typeface="Calibri" pitchFamily="34" charset="-122"/>
                 <a:cs typeface="Calibri" pitchFamily="34" charset="-120"/>
               </a:rPr>
-              <a:t>L2 10.2 实战工作流（建议先从 WhatsApp/邮件线索开始）</a:t>
+              <a:t>L3 10.1 外贸电商的“高价值环节”在哪里</a:t>
             </a:r>
             <a:endParaRPr lang="en-US" sz="1400" dirty="0"/>
           </a:p>
@@ -23199,7 +23199,7 @@
           <a:bodyPr wrap="square" lIns="0" tIns="0" rIns="0" bIns="0" rtlCol="0" anchor="t"/>
           <a:lstStyle/>
           <a:p>
-            <a:pPr lvl="1" marL="685800" indent="-342900">
+            <a:pPr lvl="2" marL="1028700" indent="-342900">
               <a:spcAft>
                 <a:spcPts val="400"/>
               </a:spcAft>
@@ -23215,12 +23215,12 @@
                 <a:ea typeface="Calibri" pitchFamily="34" charset="-122"/>
                 <a:cs typeface="Calibri" pitchFamily="34" charset="-120"/>
               </a:rPr>
-              <a:t>L2 10.3 预期效果（建议你现场用这 4 个指标讲）</a:t>
+              <a:t>L3 10.2 实战工作流（建议先从 WhatsApp/邮件线索开始）</a:t>
             </a:r>
             <a:endParaRPr lang="en-US" sz="1400" dirty="0"/>
           </a:p>
           <a:p>
-            <a:pPr marL="342900" indent="-342900">
+            <a:pPr lvl="2" marL="1028700" indent="-342900">
               <a:spcAft>
                 <a:spcPts val="400"/>
               </a:spcAft>
@@ -23236,7 +23236,7 @@
                 <a:ea typeface="Calibri" pitchFamily="34" charset="-122"/>
                 <a:cs typeface="Calibri" pitchFamily="34" charset="-120"/>
               </a:rPr>
-              <a:t>L1 11｜独立站品牌：内容-投放-客服-复盘一体化（实战 + 效果）</a:t>
+              <a:t>L3 10.3 预期效果（建议你现场用这 4 个指标讲）</a:t>
             </a:r>
             <a:endParaRPr lang="en-US" sz="1400" dirty="0"/>
           </a:p>
@@ -23257,12 +23257,12 @@
                 <a:ea typeface="Calibri" pitchFamily="34" charset="-122"/>
                 <a:cs typeface="Calibri" pitchFamily="34" charset="-120"/>
               </a:rPr>
-              <a:t>L2 11.1 独立站品牌最“烧钱”的 3 件事</a:t>
+              <a:t>L2 11｜独立站品牌：内容-投放-客服-复盘一体化（实战 + 效果）</a:t>
             </a:r>
             <a:endParaRPr lang="en-US" sz="1400" dirty="0"/>
           </a:p>
           <a:p>
-            <a:pPr lvl="1" marL="685800" indent="-342900">
+            <a:pPr lvl="2" marL="1028700" indent="-342900">
               <a:spcAft>
                 <a:spcPts val="400"/>
               </a:spcAft>
@@ -23278,12 +23278,12 @@
                 <a:ea typeface="Calibri" pitchFamily="34" charset="-122"/>
                 <a:cs typeface="Calibri" pitchFamily="34" charset="-120"/>
               </a:rPr>
-              <a:t>L2 11.2 实战剧本（独立站最适合用“多 Agent 分工”跑流水线）</a:t>
+              <a:t>L3 11.1 独立站品牌最“烧钱”的 3 件事</a:t>
             </a:r>
             <a:endParaRPr lang="en-US" sz="1400" dirty="0"/>
           </a:p>
           <a:p>
-            <a:pPr marL="342900" indent="-342900">
+            <a:pPr lvl="2" marL="1028700" indent="-342900">
               <a:spcAft>
                 <a:spcPts val="400"/>
               </a:spcAft>
@@ -23299,7 +23299,7 @@
                 <a:ea typeface="Calibri" pitchFamily="34" charset="-122"/>
                 <a:cs typeface="Calibri" pitchFamily="34" charset="-120"/>
               </a:rPr>
-              <a:t>L1 12｜MCN 机构：选题-脚本-制作-分发的龙虾流水线（实战 + 效果）</a:t>
+              <a:t>L3 11.2 实战剧本（独立站最适合用“多 Agent 分工”跑流水线）</a:t>
             </a:r>
             <a:endParaRPr lang="en-US" sz="1400" dirty="0"/>
           </a:p>
@@ -23320,12 +23320,12 @@
                 <a:ea typeface="Calibri" pitchFamily="34" charset="-122"/>
                 <a:cs typeface="Calibri" pitchFamily="34" charset="-120"/>
               </a:rPr>
-              <a:t>L2 12.1 MCN 的瓶颈不是创意，是“周转率”</a:t>
+              <a:t>L2 12｜MCN 机构：选题-脚本-制作-分发的龙虾流水线（实战 + 效果）</a:t>
             </a:r>
             <a:endParaRPr lang="en-US" sz="1400" dirty="0"/>
           </a:p>
           <a:p>
-            <a:pPr lvl="1" marL="685800" indent="-342900">
+            <a:pPr lvl="2" marL="1028700" indent="-342900">
               <a:spcAft>
                 <a:spcPts val="400"/>
               </a:spcAft>
@@ -23341,12 +23341,12 @@
                 <a:ea typeface="Calibri" pitchFamily="34" charset="-122"/>
                 <a:cs typeface="Calibri" pitchFamily="34" charset="-120"/>
               </a:rPr>
-              <a:t>L2 12.2 实战组织结构（一个 MCN = 一个多 Agent 小团队）</a:t>
+              <a:t>L3 12.1 MCN 的瓶颈不是创意，是“周转率”</a:t>
             </a:r>
             <a:endParaRPr lang="en-US" sz="1400" dirty="0"/>
           </a:p>
           <a:p>
-            <a:pPr lvl="1" marL="685800" indent="-342900">
+            <a:pPr lvl="2" marL="1028700" indent="-342900">
               <a:spcAft>
                 <a:spcPts val="400"/>
               </a:spcAft>
@@ -23362,12 +23362,12 @@
                 <a:ea typeface="Calibri" pitchFamily="34" charset="-122"/>
                 <a:cs typeface="Calibri" pitchFamily="34" charset="-120"/>
               </a:rPr>
-              <a:t>L2 12.3 实战工作流（你可以把它讲成 SOP）</a:t>
+              <a:t>L3 12.2 实战组织结构（一个 MCN = 一个多 Agent 小团队）</a:t>
             </a:r>
             <a:endParaRPr lang="en-US" sz="1400" dirty="0"/>
           </a:p>
           <a:p>
-            <a:pPr lvl="1" marL="685800" indent="-342900">
+            <a:pPr lvl="2" marL="1028700" indent="-342900">
               <a:spcAft>
                 <a:spcPts val="400"/>
               </a:spcAft>
@@ -23383,12 +23383,12 @@
                 <a:ea typeface="Calibri" pitchFamily="34" charset="-122"/>
                 <a:cs typeface="Calibri" pitchFamily="34" charset="-120"/>
               </a:rPr>
-              <a:t>L2 12.4 预期效果（MCN 讲这 3 个就够）</a:t>
+              <a:t>L3 12.3 实战工作流（你可以把它讲成 SOP）</a:t>
             </a:r>
             <a:endParaRPr lang="en-US" sz="1400" dirty="0"/>
           </a:p>
           <a:p>
-            <a:pPr marL="342900" indent="-342900">
+            <a:pPr lvl="2" marL="1028700" indent="-342900">
               <a:spcAft>
                 <a:spcPts val="400"/>
               </a:spcAft>
@@ -23404,7 +23404,7 @@
                 <a:ea typeface="Calibri" pitchFamily="34" charset="-122"/>
                 <a:cs typeface="Calibri" pitchFamily="34" charset="-120"/>
               </a:rPr>
-              <a:t>L1 13｜最后：如何变现？</a:t>
+              <a:t>L3 12.4 预期效果（MCN 讲这 3 个就够）</a:t>
             </a:r>
             <a:endParaRPr lang="en-US" sz="1400" dirty="0"/>
           </a:p>
@@ -23425,12 +23425,12 @@
                 <a:ea typeface="Calibri" pitchFamily="34" charset="-122"/>
                 <a:cs typeface="Calibri" pitchFamily="34" charset="-120"/>
               </a:rPr>
-              <a:t>L2 原始要点</a:t>
+              <a:t>L2 13｜最后：如何变现？</a:t>
             </a:r>
             <a:endParaRPr lang="en-US" sz="1400" dirty="0"/>
           </a:p>
           <a:p>
-            <a:pPr lvl="1" marL="685800" indent="-342900">
+            <a:pPr lvl="2" marL="1028700" indent="-342900">
               <a:spcAft>
                 <a:spcPts val="400"/>
               </a:spcAft>
@@ -23446,12 +23446,12 @@
                 <a:ea typeface="Calibri" pitchFamily="34" charset="-122"/>
                 <a:cs typeface="Calibri" pitchFamily="34" charset="-120"/>
               </a:rPr>
-              <a:t>L2 用户画像（3 类）</a:t>
+              <a:t>L3 原始要点</a:t>
             </a:r>
             <a:endParaRPr lang="en-US" sz="1400" dirty="0"/>
           </a:p>
           <a:p>
-            <a:pPr lvl="1" marL="685800" indent="-342900">
+            <a:pPr lvl="2" marL="1028700" indent="-342900">
               <a:spcAft>
                 <a:spcPts val="400"/>
               </a:spcAft>
@@ -23467,12 +23467,12 @@
                 <a:ea typeface="Calibri" pitchFamily="34" charset="-122"/>
                 <a:cs typeface="Calibri" pitchFamily="34" charset="-120"/>
               </a:rPr>
-              <a:t>L2 互联网补充：按画像设计“价格锚点”（更易成交）</a:t>
+              <a:t>L3 用户画像（3 类）</a:t>
             </a:r>
             <a:endParaRPr lang="en-US" sz="1400" dirty="0"/>
           </a:p>
           <a:p>
-            <a:pPr marL="342900" indent="-342900">
+            <a:pPr lvl="2" marL="1028700" indent="-342900">
               <a:spcAft>
                 <a:spcPts val="400"/>
               </a:spcAft>
@@ -23488,12 +23488,12 @@
                 <a:ea typeface="Calibri" pitchFamily="34" charset="-122"/>
                 <a:cs typeface="Calibri" pitchFamily="34" charset="-120"/>
               </a:rPr>
-              <a:t>L1 参考资料（互联网来源）</a:t>
+              <a:t>L3 互联网补充：按画像设计“价格锚点”（更易成交）</a:t>
             </a:r>
             <a:endParaRPr lang="en-US" sz="1400" dirty="0"/>
           </a:p>
           <a:p>
-            <a:pPr marL="342900" indent="-342900">
+            <a:pPr lvl="1" marL="685800" indent="-342900">
               <a:spcAft>
                 <a:spcPts val="400"/>
               </a:spcAft>
@@ -23509,7 +23509,7 @@
                 <a:ea typeface="Calibri" pitchFamily="34" charset="-122"/>
                 <a:cs typeface="Calibri" pitchFamily="34" charset="-120"/>
               </a:rPr>
-              <a:t>L1 附录A｜国内检索案例库（百度检索 + 打开核验）</a:t>
+              <a:t>L2 参考资料（互联网来源）</a:t>
             </a:r>
             <a:endParaRPr lang="en-US" sz="1400" dirty="0"/>
           </a:p>
@@ -23530,7 +23530,7 @@
                 <a:ea typeface="Calibri" pitchFamily="34" charset="-122"/>
                 <a:cs typeface="Calibri" pitchFamily="34" charset="-120"/>
               </a:rPr>
-              <a:t>L2 A.1 ToC（个人/副业/在岗）</a:t>
+              <a:t>L2 附录A｜国内检索案例库（百度检索 + 打开核验）</a:t>
             </a:r>
             <a:endParaRPr lang="en-US" sz="1400" dirty="0"/>
           </a:p>
@@ -23551,12 +23551,12 @@
                 <a:ea typeface="Calibri" pitchFamily="34" charset="-122"/>
                 <a:cs typeface="Calibri" pitchFamily="34" charset="-120"/>
               </a:rPr>
-              <a:t>L3 A.1.1 麦当劳专属“营养师”+ 自动领券（mcd Skill）</a:t>
+              <a:t>L3 A.1 ToC（个人/副业/在岗）</a:t>
             </a:r>
             <a:endParaRPr lang="en-US" sz="1400" dirty="0"/>
           </a:p>
           <a:p>
-            <a:pPr lvl="2" marL="1028700" indent="-342900">
+            <a:pPr lvl="3" marL="1371600" indent="-342900">
               <a:spcAft>
                 <a:spcPts val="400"/>
               </a:spcAft>
@@ -23572,7 +23572,7 @@
                 <a:ea typeface="Calibri" pitchFamily="34" charset="-122"/>
                 <a:cs typeface="Calibri" pitchFamily="34" charset="-120"/>
               </a:rPr>
-              <a:t>L3 A.1.2 10 分钟打造 AI 选股系统（实时行情 API + 调度）</a:t>
+              <a:t>L4 A.1.1 麦当劳专属“营养师”+ 自动领券（mcd Skill）</a:t>
             </a:r>
             <a:endParaRPr lang="en-US" sz="1400" dirty="0"/>
           </a:p>
@@ -24327,7 +24327,7 @@
           <a:bodyPr wrap="square" lIns="0" tIns="0" rIns="0" bIns="0" rtlCol="0" anchor="t"/>
           <a:lstStyle/>
           <a:p>
-            <a:pPr lvl="2" marL="1028700" indent="-342900">
+            <a:pPr lvl="3" marL="1371600" indent="-342900">
               <a:spcAft>
                 <a:spcPts val="400"/>
               </a:spcAft>
@@ -24343,12 +24343,12 @@
                 <a:ea typeface="Calibri" pitchFamily="34" charset="-122"/>
                 <a:cs typeface="Calibri" pitchFamily="34" charset="-120"/>
               </a:rPr>
-              <a:t>L3 A.1.3 云服务器部署 Skill，飞书直连 iPhone（苹果生态）</a:t>
+              <a:t>L4 A.1.2 10 分钟打造 AI 选股系统（实时行情 API + 调度）</a:t>
             </a:r>
             <a:endParaRPr lang="en-US" sz="1400" dirty="0"/>
           </a:p>
           <a:p>
-            <a:pPr lvl="1" marL="685800" indent="-342900">
+            <a:pPr lvl="3" marL="1371600" indent="-342900">
               <a:spcAft>
                 <a:spcPts val="400"/>
               </a:spcAft>
@@ -24364,7 +24364,7 @@
                 <a:ea typeface="Calibri" pitchFamily="34" charset="-122"/>
                 <a:cs typeface="Calibri" pitchFamily="34" charset="-120"/>
               </a:rPr>
-              <a:t>L2 A.2 自媒体（内容生产/发布自动化）</a:t>
+              <a:t>L4 A.1.3 云服务器部署 Skill，飞书直连 iPhone（苹果生态）</a:t>
             </a:r>
             <a:endParaRPr lang="en-US" sz="1400" dirty="0"/>
           </a:p>
@@ -24385,12 +24385,12 @@
                 <a:ea typeface="Calibri" pitchFamily="34" charset="-122"/>
                 <a:cs typeface="Calibri" pitchFamily="34" charset="-120"/>
               </a:rPr>
-              <a:t>L3 A.2.1 小红书全自动：热点→文案→封面→自动发布（xhs Skill）</a:t>
+              <a:t>L3 A.2 自媒体（内容生产/发布自动化）</a:t>
             </a:r>
             <a:endParaRPr lang="en-US" sz="1400" dirty="0"/>
           </a:p>
           <a:p>
-            <a:pPr lvl="1" marL="685800" indent="-342900">
+            <a:pPr lvl="3" marL="1371600" indent="-342900">
               <a:spcAft>
                 <a:spcPts val="400"/>
               </a:spcAft>
@@ -24406,7 +24406,7 @@
                 <a:ea typeface="Calibri" pitchFamily="34" charset="-122"/>
                 <a:cs typeface="Calibri" pitchFamily="34" charset="-120"/>
               </a:rPr>
-              <a:t>L2 A.3 ToB（企业/团队）</a:t>
+              <a:t>L4 A.2.1 小红书全自动：热点→文案→封面→自动发布（xhs Skill）</a:t>
             </a:r>
             <a:endParaRPr lang="en-US" sz="1400" dirty="0"/>
           </a:p>
@@ -24427,12 +24427,12 @@
                 <a:ea typeface="Calibri" pitchFamily="34" charset="-122"/>
                 <a:cs typeface="Calibri" pitchFamily="34" charset="-120"/>
               </a:rPr>
-              <a:t>L3 A.3.1 OpenClaw 接入飞书云文档/权限/导出：把机器人变成“文档操作员”</a:t>
+              <a:t>L3 A.3 ToB（企业/团队）</a:t>
             </a:r>
             <a:endParaRPr lang="en-US" sz="1400" dirty="0"/>
           </a:p>
           <a:p>
-            <a:pPr lvl="2" marL="1028700" indent="-342900">
+            <a:pPr lvl="3" marL="1371600" indent="-342900">
               <a:spcAft>
                 <a:spcPts val="400"/>
               </a:spcAft>
@@ -24448,12 +24448,12 @@
                 <a:ea typeface="Calibri" pitchFamily="34" charset="-122"/>
                 <a:cs typeface="Calibri" pitchFamily="34" charset="-120"/>
               </a:rPr>
-              <a:t>L3 A.3.2（待补齐正文）睡个午觉，OpenClaw 已经帮我把网站写好部署上线了</a:t>
+              <a:t>L4 A.3.1 OpenClaw 接入飞书云文档/权限/导出：把机器人变成“文档操作员”</a:t>
             </a:r>
             <a:endParaRPr lang="en-US" sz="1400" dirty="0"/>
           </a:p>
           <a:p>
-            <a:pPr lvl="1" marL="685800" indent="-342900">
+            <a:pPr lvl="3" marL="1371600" indent="-342900">
               <a:spcAft>
                 <a:spcPts val="400"/>
               </a:spcAft>
@@ -24469,12 +24469,12 @@
                 <a:ea typeface="Calibri" pitchFamily="34" charset="-122"/>
                 <a:cs typeface="Calibri" pitchFamily="34" charset="-120"/>
               </a:rPr>
-              <a:t>L2 A.4 百度检索关键词（可复用）</a:t>
+              <a:t>L4 A.3.2（待补齐正文）睡个午觉，OpenClaw 已经帮我把网站写好部署上线了</a:t>
             </a:r>
             <a:endParaRPr lang="en-US" sz="1400" dirty="0"/>
           </a:p>
           <a:p>
-            <a:pPr lvl="1" marL="685800" indent="-342900">
+            <a:pPr lvl="2" marL="1028700" indent="-342900">
               <a:spcAft>
                 <a:spcPts val="400"/>
               </a:spcAft>
@@ -24490,7 +24490,28 @@
                 <a:ea typeface="Calibri" pitchFamily="34" charset="-122"/>
                 <a:cs typeface="Calibri" pitchFamily="34" charset="-120"/>
               </a:rPr>
-              <a:t>L2 A.5 国内案例信源（引用清单）</a:t>
+              <a:t>L3 A.4 百度检索关键词（可复用）</a:t>
+            </a:r>
+            <a:endParaRPr lang="en-US" sz="1400" dirty="0"/>
+          </a:p>
+          <a:p>
+            <a:pPr lvl="2" marL="1028700" indent="-342900">
+              <a:spcAft>
+                <a:spcPts val="400"/>
+              </a:spcAft>
+              <a:buSzPct val="100000"/>
+              <a:buChar char="•"/>
+            </a:pPr>
+            <a:r>
+              <a:rPr lang="en-US" sz="1400" dirty="0">
+                <a:solidFill>
+                  <a:srgbClr val="E5E7EB"/>
+                </a:solidFill>
+                <a:latin typeface="Calibri" pitchFamily="34" charset="0"/>
+                <a:ea typeface="Calibri" pitchFamily="34" charset="-122"/>
+                <a:cs typeface="Calibri" pitchFamily="34" charset="-120"/>
+              </a:rPr>
+              <a:t>L3 A.5 国内案例信源（引用清单）</a:t>
             </a:r>
             <a:endParaRPr lang="en-US" sz="1400" dirty="0"/>
           </a:p>

</xml_diff>